<commit_message>
Week7: update laporan kelompok/individu dan PPT ke uji 3 jalur + spesifikasi sensor api
Co-Authored-By: Claude Sonnet 5.5 <noreply@anthropic.com>
Claude-Session: https://claude.ai/code/session_01EFAKZhib7CvMuWHfhRrZHZ
</commit_message>
<xml_diff>
--- a/Week7/PPT_SAFE-EXIT_Pekan7_Kelompok21_MBB.pptx
+++ b/Week7/PPT_SAFE-EXIT_Pekan7_Kelompok21_MBB.pptx
@@ -12,6 +12,7 @@
     <p:sldId id="260" r:id="rId12"/>
     <p:sldId id="261" r:id="rId13"/>
     <p:sldId id="262" r:id="rId14"/>
+    <p:sldId id="263" r:id="rId15"/>
   </p:sldIdLst>
   <p:sldSz cx="9144000" cy="5143500" type="screen4x3"/>
   <p:notesSz cx="6858000" cy="9144000"/>
@@ -4175,7 +4176,7 @@
                 </a:solidFill>
                 <a:latin typeface="Georgia"/>
               </a:rPr>
-              <a:t>Dua dari tiga target Pekan 7 tercapai; uji penuh 20 jalur bergeser ke Pekan 8</a:t>
+              <a:t>Uji 3 jalur berhasil; LED dan sensor tinggal ditempel pada maket</a:t>
             </a:r>
           </a:p>
         </p:txBody>
@@ -4270,7 +4271,7 @@
                 </a:solidFill>
                 <a:latin typeface="Arial"/>
               </a:rPr>
-              <a:t>Catatan: PSU = power supply 5 V. Jalur teruji dibatasi oleh kabel PSU yang bermasalah.</a:t>
+              <a:t>Catatan: uji 5 jalur terkendala arus catu dan konektor power supply (PSU), sehingga uji disederhanakan ke 3 jalur.</a:t>
             </a:r>
           </a:p>
         </p:txBody>
@@ -4672,7 +4673,7 @@
                 </a:solidFill>
                 <a:latin typeface="Georgia"/>
               </a:rPr>
-              <a:t>5 / 20</a:t>
+              <a:t>3 / 3</a:t>
             </a:r>
           </a:p>
         </p:txBody>
@@ -4707,7 +4708,7 @@
                 </a:solidFill>
                 <a:latin typeface="Arial"/>
               </a:rPr>
-              <a:t>jalur teruji</a:t>
+              <a:t>jalur uji berhasil</a:t>
             </a:r>
           </a:p>
           <a:p>
@@ -4723,7 +4724,7 @@
                 </a:solidFill>
                 <a:latin typeface="Arial"/>
               </a:rPr>
-              <a:t>(kabel PSU bermasalah)</a:t>
+              <a:t>(18 LED, 3 sensor api)</a:t>
             </a:r>
           </a:p>
         </p:txBody>
@@ -4754,11 +4755,11 @@
             <a:r>
               <a:rPr sz="900" b="1">
                 <a:solidFill>
-                  <a:srgbClr val="B71C1C"/>
+                  <a:srgbClr val="2E7D32"/>
                 </a:solidFill>
                 <a:latin typeface="Arial"/>
               </a:rPr>
-              <a:t>BELUM TERCAPAI</a:t>
+              <a:t>BERHASIL</a:t>
             </a:r>
           </a:p>
         </p:txBody>
@@ -4853,7 +4854,7 @@
                 </a:solidFill>
                 <a:latin typeface="Arial"/>
               </a:rPr>
-              <a:t>Integrasi 20 jalur dengan power supply 5 V tertunda; dikejar awal Pekan 8.</a:t>
+              <a:t>Berikutnya: tempel di maket Gedung K; uji 20 jalur setelah konektor PSU diperbaiki.</a:t>
             </a:r>
           </a:p>
         </p:txBody>
@@ -6831,7 +6832,7 @@
                 </a:solidFill>
                 <a:latin typeface="Georgia"/>
               </a:rPr>
-              <a:t>Uji dibatasi 5 jalur fisik; peta Dijkstra tetap 20 jalur dan sisanya disimulasikan</a:t>
+              <a:t>Uji 3 jalur berhasil: 18 LED dan 3 sensor api; peta Dijkstra tetap 20 jalur</a:t>
             </a:r>
           </a:p>
         </p:txBody>
@@ -6926,7 +6927,7 @@
                 </a:solidFill>
                 <a:latin typeface="Arial"/>
               </a:rPr>
-              <a:t>Catatan: 34 LED ≈ 0,45 A (perkiraan). Jalur lain disimulasikan lewat Serial: block j6-j7, clear, reset.</a:t>
+              <a:t>Catatan: 18 LED ≈ 0,24 A (perkiraan dari 0,45 A untuk 34 LED). Jalur lain disimulasikan lewat Serial.</a:t>
             </a:r>
           </a:p>
         </p:txBody>
@@ -6976,7 +6977,7 @@
         </p:nvGraphicFramePr>
         <p:xfrm>
           <a:off x="457200" y="1325880"/>
-          <a:ext cx="5394960" cy="2633472"/>
+          <a:ext cx="5394960" cy="1755648"/>
         </p:xfrm>
         <a:graphic>
           <a:graphicData uri="http://schemas.openxmlformats.org/drawingml/2006/table">
@@ -6986,9 +6987,9 @@
               </a:tblPr>
               <a:tblGrid>
                 <a:gridCol w="731520"/>
-                <a:gridCol w="1097280"/>
-                <a:gridCol w="731520"/>
-                <a:gridCol w="1280160"/>
+                <a:gridCol w="1005840"/>
+                <a:gridCol w="640080"/>
+                <a:gridCol w="1463040"/>
                 <a:gridCol w="1554480"/>
               </a:tblGrid>
               <a:tr h="438912">
@@ -7191,7 +7192,7 @@
                           </a:solidFill>
                           <a:latin typeface="Arial"/>
                         </a:rPr>
-                        <a:t>GPIO 4</a:t>
+                        <a:t>GPIO 5 (D5)</a:t>
                       </a:r>
                     </a:p>
                   </a:txBody>
@@ -7215,240 +7216,6 @@
                           <a:latin typeface="Arial"/>
                         </a:rPr>
                         <a:t>GPIO 32</a:t>
-                      </a:r>
-                    </a:p>
-                  </a:txBody>
-                  <a:tcPr anchor="ctr" marL="109728">
-                    <a:solidFill>
-                      <a:srgbClr val="FFFFFF"/>
-                    </a:solidFill>
-                  </a:tcPr>
-                </a:tc>
-              </a:tr>
-              <a:tr h="438912">
-                <a:tc>
-                  <a:txBody>
-                    <a:bodyPr/>
-                    <a:lstStyle/>
-                    <a:p>
-                      <a:pPr algn="l"/>
-                      <a:r>
-                        <a:rPr sz="1100" b="0">
-                          <a:solidFill>
-                            <a:srgbClr val="595959"/>
-                          </a:solidFill>
-                          <a:latin typeface="Arial"/>
-                        </a:rPr>
-                        <a:t>#11</a:t>
-                      </a:r>
-                    </a:p>
-                  </a:txBody>
-                  <a:tcPr anchor="ctr" marL="109728">
-                    <a:solidFill>
-                      <a:srgbClr val="F2F4F7"/>
-                    </a:solidFill>
-                  </a:tcPr>
-                </a:tc>
-                <a:tc>
-                  <a:txBody>
-                    <a:bodyPr/>
-                    <a:lstStyle/>
-                    <a:p>
-                      <a:pPr algn="l"/>
-                      <a:r>
-                        <a:rPr sz="1100" b="0">
-                          <a:solidFill>
-                            <a:srgbClr val="595959"/>
-                          </a:solidFill>
-                          <a:latin typeface="Arial"/>
-                        </a:rPr>
-                        <a:t>j7-j9</a:t>
-                      </a:r>
-                    </a:p>
-                  </a:txBody>
-                  <a:tcPr anchor="ctr" marL="109728">
-                    <a:solidFill>
-                      <a:srgbClr val="F2F4F7"/>
-                    </a:solidFill>
-                  </a:tcPr>
-                </a:tc>
-                <a:tc>
-                  <a:txBody>
-                    <a:bodyPr/>
-                    <a:lstStyle/>
-                    <a:p>
-                      <a:pPr algn="l"/>
-                      <a:r>
-                        <a:rPr sz="1100" b="0">
-                          <a:solidFill>
-                            <a:srgbClr val="595959"/>
-                          </a:solidFill>
-                          <a:latin typeface="Arial"/>
-                        </a:rPr>
-                        <a:t>8</a:t>
-                      </a:r>
-                    </a:p>
-                  </a:txBody>
-                  <a:tcPr anchor="ctr" marL="109728">
-                    <a:solidFill>
-                      <a:srgbClr val="F2F4F7"/>
-                    </a:solidFill>
-                  </a:tcPr>
-                </a:tc>
-                <a:tc>
-                  <a:txBody>
-                    <a:bodyPr/>
-                    <a:lstStyle/>
-                    <a:p>
-                      <a:pPr algn="l"/>
-                      <a:r>
-                        <a:rPr sz="1100" b="0">
-                          <a:solidFill>
-                            <a:srgbClr val="595959"/>
-                          </a:solidFill>
-                          <a:latin typeface="Arial"/>
-                        </a:rPr>
-                        <a:t>GPIO 5</a:t>
-                      </a:r>
-                    </a:p>
-                  </a:txBody>
-                  <a:tcPr anchor="ctr" marL="109728">
-                    <a:solidFill>
-                      <a:srgbClr val="F2F4F7"/>
-                    </a:solidFill>
-                  </a:tcPr>
-                </a:tc>
-                <a:tc>
-                  <a:txBody>
-                    <a:bodyPr/>
-                    <a:lstStyle/>
-                    <a:p>
-                      <a:pPr algn="l"/>
-                      <a:r>
-                        <a:rPr sz="1100" b="0">
-                          <a:solidFill>
-                            <a:srgbClr val="595959"/>
-                          </a:solidFill>
-                          <a:latin typeface="Arial"/>
-                        </a:rPr>
-                        <a:t>GPIO 33</a:t>
-                      </a:r>
-                    </a:p>
-                  </a:txBody>
-                  <a:tcPr anchor="ctr" marL="109728">
-                    <a:solidFill>
-                      <a:srgbClr val="F2F4F7"/>
-                    </a:solidFill>
-                  </a:tcPr>
-                </a:tc>
-              </a:tr>
-              <a:tr h="438912">
-                <a:tc>
-                  <a:txBody>
-                    <a:bodyPr/>
-                    <a:lstStyle/>
-                    <a:p>
-                      <a:pPr algn="l"/>
-                      <a:r>
-                        <a:rPr sz="1100" b="0">
-                          <a:solidFill>
-                            <a:srgbClr val="595959"/>
-                          </a:solidFill>
-                          <a:latin typeface="Arial"/>
-                        </a:rPr>
-                        <a:t>#15</a:t>
-                      </a:r>
-                    </a:p>
-                  </a:txBody>
-                  <a:tcPr anchor="ctr" marL="109728">
-                    <a:solidFill>
-                      <a:srgbClr val="FFFFFF"/>
-                    </a:solidFill>
-                  </a:tcPr>
-                </a:tc>
-                <a:tc>
-                  <a:txBody>
-                    <a:bodyPr/>
-                    <a:lstStyle/>
-                    <a:p>
-                      <a:pPr algn="l"/>
-                      <a:r>
-                        <a:rPr sz="1100" b="0">
-                          <a:solidFill>
-                            <a:srgbClr val="595959"/>
-                          </a:solidFill>
-                          <a:latin typeface="Arial"/>
-                        </a:rPr>
-                        <a:t>j10-j12</a:t>
-                      </a:r>
-                    </a:p>
-                  </a:txBody>
-                  <a:tcPr anchor="ctr" marL="109728">
-                    <a:solidFill>
-                      <a:srgbClr val="FFFFFF"/>
-                    </a:solidFill>
-                  </a:tcPr>
-                </a:tc>
-                <a:tc>
-                  <a:txBody>
-                    <a:bodyPr/>
-                    <a:lstStyle/>
-                    <a:p>
-                      <a:pPr algn="l"/>
-                      <a:r>
-                        <a:rPr sz="1100" b="0">
-                          <a:solidFill>
-                            <a:srgbClr val="595959"/>
-                          </a:solidFill>
-                          <a:latin typeface="Arial"/>
-                        </a:rPr>
-                        <a:t>8</a:t>
-                      </a:r>
-                    </a:p>
-                  </a:txBody>
-                  <a:tcPr anchor="ctr" marL="109728">
-                    <a:solidFill>
-                      <a:srgbClr val="FFFFFF"/>
-                    </a:solidFill>
-                  </a:tcPr>
-                </a:tc>
-                <a:tc>
-                  <a:txBody>
-                    <a:bodyPr/>
-                    <a:lstStyle/>
-                    <a:p>
-                      <a:pPr algn="l"/>
-                      <a:r>
-                        <a:rPr sz="1100" b="0">
-                          <a:solidFill>
-                            <a:srgbClr val="595959"/>
-                          </a:solidFill>
-                          <a:latin typeface="Arial"/>
-                        </a:rPr>
-                        <a:t>GPIO 13</a:t>
-                      </a:r>
-                    </a:p>
-                  </a:txBody>
-                  <a:tcPr anchor="ctr" marL="109728">
-                    <a:solidFill>
-                      <a:srgbClr val="FFFFFF"/>
-                    </a:solidFill>
-                  </a:tcPr>
-                </a:tc>
-                <a:tc>
-                  <a:txBody>
-                    <a:bodyPr/>
-                    <a:lstStyle/>
-                    <a:p>
-                      <a:pPr algn="l"/>
-                      <a:r>
-                        <a:rPr sz="1100" b="0">
-                          <a:solidFill>
-                            <a:srgbClr val="595959"/>
-                          </a:solidFill>
-                          <a:latin typeface="Arial"/>
-                        </a:rPr>
-                        <a:t>GPIO 34</a:t>
                       </a:r>
                     </a:p>
                   </a:txBody>
@@ -7542,7 +7309,7 @@
                           </a:solidFill>
                           <a:latin typeface="Arial"/>
                         </a:rPr>
-                        <a:t>GPIO 14</a:t>
+                        <a:t>GPIO 13 (D13)</a:t>
                       </a:r>
                     </a:p>
                   </a:txBody>
@@ -7565,7 +7332,7 @@
                           </a:solidFill>
                           <a:latin typeface="Arial"/>
                         </a:rPr>
-                        <a:t>GPIO 35</a:t>
+                        <a:t>GPIO 33</a:t>
                       </a:r>
                     </a:p>
                   </a:txBody>
@@ -7659,7 +7426,7 @@
                           </a:solidFill>
                           <a:latin typeface="Arial"/>
                         </a:rPr>
-                        <a:t>GPIO 18</a:t>
+                        <a:t>GPIO 14 (D14)</a:t>
                       </a:r>
                     </a:p>
                   </a:txBody>
@@ -7682,7 +7449,7 @@
                           </a:solidFill>
                           <a:latin typeface="Arial"/>
                         </a:rPr>
-                        <a:t>GPIO 36</a:t>
+                        <a:t>GPIO 34</a:t>
                       </a:r>
                     </a:p>
                   </a:txBody>
@@ -7706,7 +7473,7 @@
         <p:spPr>
           <a:xfrm>
             <a:off x="6217920" y="1325880"/>
-            <a:ext cx="45720" cy="2651760"/>
+            <a:ext cx="45720" cy="2011680"/>
           </a:xfrm>
           <a:prstGeom prst="rect">
             <a:avLst/>
@@ -7757,7 +7524,7 @@
                 </a:solidFill>
                 <a:latin typeface="Arial"/>
               </a:rPr>
-              <a:t>Kenapa 5 jalur?</a:t>
+              <a:t>Kenapa 3 jalur?</a:t>
             </a:r>
           </a:p>
         </p:txBody>
@@ -7792,7 +7559,7 @@
                 </a:solidFill>
                 <a:latin typeface="Arial"/>
               </a:rPr>
-              <a:t>Kabel PSU belum bisa dipakai, sehingga power supply 5 V tidak bisa dipakai.</a:t>
+              <a:t>Uji 5 jalur terkendala: arus catu kurang kuat dan konektor power supply bermasalah.</a:t>
             </a:r>
           </a:p>
           <a:p>
@@ -7808,7 +7575,7 @@
                 </a:solidFill>
                 <a:latin typeface="Arial"/>
               </a:rPr>
-              <a:t>34 LED cukup dari USB laptop (perkiraan ±0,45 A).</a:t>
+              <a:t>3 jalur (18 LED) berhasil dari sensor hingga LED; tinggal ditempel di maket.</a:t>
             </a:r>
           </a:p>
         </p:txBody>
@@ -7861,7 +7628,7 @@
                 </a:solidFill>
                 <a:latin typeface="Georgia"/>
               </a:rPr>
-              <a:t>Tiga kendala sudah punya mitigasi; uji penuh 20 jalur digeser ke Pekan 8</a:t>
+              <a:t>Sensor api memindai 760–1100 nm pada ±60°, dibaca ADC 12 bit dengan ambang 1500 / 1800</a:t>
             </a:r>
           </a:p>
         </p:txBody>
@@ -7956,7 +7723,7 @@
                 </a:solidFill>
                 <a:latin typeface="Arial"/>
               </a:rPr>
-              <a:t>Catatan: deviasi = penyolderan terlambat ±1 pekan; kode sesuai jadwal; uji penuh digeser ke Pekan 8.</a:t>
+              <a:t>Catatan: spesifikasi modul adalah tipikal datasheet (flame sensor LM393), bukan hasil ukur. Jarak deteksi aktual diukur di maket.</a:t>
             </a:r>
           </a:p>
         </p:txBody>
@@ -7996,501 +7763,400 @@
           </a:p>
         </p:txBody>
       </p:sp>
-      <p:sp>
-        <p:nvSpPr>
-          <p:cNvPr id="7" name="TextBox 6"/>
-          <p:cNvSpPr txBox="1"/>
-          <p:nvPr/>
-        </p:nvSpPr>
-        <p:spPr>
-          <a:xfrm>
-            <a:off x="457200" y="1280160"/>
-            <a:ext cx="3291840" cy="274320"/>
-          </a:xfrm>
-          <a:prstGeom prst="rect">
-            <a:avLst/>
-          </a:prstGeom>
-          <a:noFill/>
-        </p:spPr>
-        <p:txBody>
-          <a:bodyPr wrap="square" lIns="0" rIns="0" tIns="0" bIns="0" anchor="t">
-            <a:spAutoFit/>
-          </a:bodyPr>
-          <a:lstStyle/>
-          <a:p>
-            <a:pPr algn="l"/>
-            <a:r>
-              <a:rPr sz="1000" b="1">
-                <a:solidFill>
-                  <a:srgbClr val="8A9BB0"/>
-                </a:solidFill>
-                <a:latin typeface="Arial"/>
-              </a:rPr>
-              <a:t>Kendala</a:t>
-            </a:r>
-          </a:p>
-        </p:txBody>
-      </p:sp>
-      <p:sp>
-        <p:nvSpPr>
-          <p:cNvPr id="8" name="TextBox 7"/>
-          <p:cNvSpPr txBox="1"/>
-          <p:nvPr/>
-        </p:nvSpPr>
-        <p:spPr>
-          <a:xfrm>
-            <a:off x="4023360" y="1280160"/>
-            <a:ext cx="4572000" cy="274320"/>
-          </a:xfrm>
-          <a:prstGeom prst="rect">
-            <a:avLst/>
-          </a:prstGeom>
-          <a:noFill/>
-        </p:spPr>
-        <p:txBody>
-          <a:bodyPr wrap="square" lIns="0" rIns="0" tIns="0" bIns="0" anchor="t">
-            <a:spAutoFit/>
-          </a:bodyPr>
-          <a:lstStyle/>
-          <a:p>
-            <a:pPr algn="l"/>
-            <a:r>
-              <a:rPr sz="1000" b="1">
-                <a:solidFill>
-                  <a:srgbClr val="8A9BB0"/>
-                </a:solidFill>
-                <a:latin typeface="Arial"/>
-              </a:rPr>
-              <a:t>Solusi / mitigasi</a:t>
-            </a:r>
-          </a:p>
-        </p:txBody>
-      </p:sp>
-      <p:sp>
-        <p:nvSpPr>
-          <p:cNvPr id="9" name="Rectangle 8"/>
-          <p:cNvSpPr/>
-          <p:nvPr/>
-        </p:nvSpPr>
-        <p:spPr>
-          <a:xfrm>
-            <a:off x="457200" y="1554480"/>
-            <a:ext cx="8229600" cy="9525"/>
-          </a:xfrm>
-          <a:prstGeom prst="rect">
-            <a:avLst/>
-          </a:prstGeom>
-          <a:solidFill>
-            <a:srgbClr val="0B2545"/>
-          </a:solidFill>
-          <a:ln>
-            <a:noFill/>
-          </a:ln>
-          <a:effectLst/>
-        </p:spPr>
-        <p:txBody>
-          <a:bodyPr rtlCol="0" anchor="ctr"/>
-          <a:lstStyle/>
-          <a:p>
-            <a:pPr algn="ctr"/>
-          </a:p>
-        </p:txBody>
-      </p:sp>
-      <p:sp>
-        <p:nvSpPr>
-          <p:cNvPr id="10" name="TextBox 9"/>
-          <p:cNvSpPr txBox="1"/>
-          <p:nvPr/>
-        </p:nvSpPr>
-        <p:spPr>
-          <a:xfrm>
-            <a:off x="457200" y="1691640"/>
-            <a:ext cx="3291840" cy="548640"/>
-          </a:xfrm>
-          <a:prstGeom prst="rect">
-            <a:avLst/>
-          </a:prstGeom>
-          <a:noFill/>
-        </p:spPr>
-        <p:txBody>
-          <a:bodyPr wrap="square" lIns="0" rIns="0" tIns="0" bIns="0" anchor="ctr">
-            <a:spAutoFit/>
-          </a:bodyPr>
-          <a:lstStyle/>
-          <a:p>
-            <a:pPr algn="l"/>
-            <a:r>
-              <a:rPr sz="1200" b="1">
-                <a:solidFill>
-                  <a:srgbClr val="0B2545"/>
-                </a:solidFill>
-                <a:latin typeface="Arial"/>
-              </a:rPr>
-              <a:t>Kabel PSU tidak bisa dipakai</a:t>
-            </a:r>
-          </a:p>
-        </p:txBody>
-      </p:sp>
-      <p:sp>
-        <p:nvSpPr>
-          <p:cNvPr id="11" name="TextBox 10"/>
-          <p:cNvSpPr txBox="1"/>
-          <p:nvPr/>
-        </p:nvSpPr>
-        <p:spPr>
-          <a:xfrm>
-            <a:off x="4023360" y="1691640"/>
-            <a:ext cx="4663440" cy="548640"/>
-          </a:xfrm>
-          <a:prstGeom prst="rect">
-            <a:avLst/>
-          </a:prstGeom>
-          <a:noFill/>
-        </p:spPr>
-        <p:txBody>
-          <a:bodyPr wrap="square" lIns="0" rIns="0" tIns="0" bIns="0" anchor="ctr">
-            <a:spAutoFit/>
-          </a:bodyPr>
-          <a:lstStyle/>
-          <a:p>
-            <a:pPr algn="l"/>
-            <a:r>
-              <a:rPr sz="1100" b="0">
-                <a:solidFill>
-                  <a:srgbClr val="595959"/>
-                </a:solidFill>
-                <a:latin typeface="Arial"/>
-              </a:rPr>
-              <a:t>Uji dialihkan ke 5 jalur via USB; perbaiki / ganti kabel PSU</a:t>
-            </a:r>
-          </a:p>
-        </p:txBody>
-      </p:sp>
-      <p:sp>
-        <p:nvSpPr>
-          <p:cNvPr id="12" name="Rectangle 11"/>
-          <p:cNvSpPr/>
-          <p:nvPr/>
-        </p:nvSpPr>
-        <p:spPr>
-          <a:xfrm>
-            <a:off x="457200" y="2331720"/>
-            <a:ext cx="8229600" cy="6350"/>
-          </a:xfrm>
-          <a:prstGeom prst="rect">
-            <a:avLst/>
-          </a:prstGeom>
-          <a:solidFill>
-            <a:srgbClr val="D9D9D9"/>
-          </a:solidFill>
-          <a:ln>
-            <a:noFill/>
-          </a:ln>
-          <a:effectLst/>
-        </p:spPr>
-        <p:txBody>
-          <a:bodyPr rtlCol="0" anchor="ctr"/>
-          <a:lstStyle/>
-          <a:p>
-            <a:pPr algn="ctr"/>
-          </a:p>
-        </p:txBody>
-      </p:sp>
-      <p:sp>
-        <p:nvSpPr>
-          <p:cNvPr id="13" name="TextBox 12"/>
-          <p:cNvSpPr txBox="1"/>
-          <p:nvPr/>
-        </p:nvSpPr>
-        <p:spPr>
-          <a:xfrm>
-            <a:off x="457200" y="2423160"/>
-            <a:ext cx="3291840" cy="548640"/>
-          </a:xfrm>
-          <a:prstGeom prst="rect">
-            <a:avLst/>
-          </a:prstGeom>
-          <a:noFill/>
-        </p:spPr>
-        <p:txBody>
-          <a:bodyPr wrap="square" lIns="0" rIns="0" tIns="0" bIns="0" anchor="ctr">
-            <a:spAutoFit/>
-          </a:bodyPr>
-          <a:lstStyle/>
-          <a:p>
-            <a:pPr algn="l"/>
-            <a:r>
-              <a:rPr sz="1200" b="1">
-                <a:solidFill>
-                  <a:srgbClr val="0B2545"/>
-                </a:solidFill>
-                <a:latin typeface="Arial"/>
-              </a:rPr>
-              <a:t>Sensor api fisik hanya 5</a:t>
-            </a:r>
-          </a:p>
-        </p:txBody>
-      </p:sp>
-      <p:sp>
-        <p:nvSpPr>
-          <p:cNvPr id="14" name="TextBox 13"/>
-          <p:cNvSpPr txBox="1"/>
-          <p:nvPr/>
-        </p:nvSpPr>
-        <p:spPr>
-          <a:xfrm>
-            <a:off x="4023360" y="2423160"/>
-            <a:ext cx="4663440" cy="548640"/>
-          </a:xfrm>
-          <a:prstGeom prst="rect">
-            <a:avLst/>
-          </a:prstGeom>
-          <a:noFill/>
-        </p:spPr>
-        <p:txBody>
-          <a:bodyPr wrap="square" lIns="0" rIns="0" tIns="0" bIns="0" anchor="ctr">
-            <a:spAutoFit/>
-          </a:bodyPr>
-          <a:lstStyle/>
-          <a:p>
-            <a:pPr algn="l"/>
-            <a:r>
-              <a:rPr sz="1100" b="0">
-                <a:solidFill>
-                  <a:srgbClr val="595959"/>
-                </a:solidFill>
-                <a:latin typeface="Arial"/>
-              </a:rPr>
-              <a:t>Jalur lain disimulasikan lewat Serial pada peta penuh</a:t>
-            </a:r>
-          </a:p>
-        </p:txBody>
-      </p:sp>
-      <p:sp>
-        <p:nvSpPr>
-          <p:cNvPr id="15" name="Rectangle 14"/>
-          <p:cNvSpPr/>
-          <p:nvPr/>
-        </p:nvSpPr>
-        <p:spPr>
-          <a:xfrm>
-            <a:off x="457200" y="3063240"/>
-            <a:ext cx="8229600" cy="6350"/>
-          </a:xfrm>
-          <a:prstGeom prst="rect">
-            <a:avLst/>
-          </a:prstGeom>
-          <a:solidFill>
-            <a:srgbClr val="D9D9D9"/>
-          </a:solidFill>
-          <a:ln>
-            <a:noFill/>
-          </a:ln>
-          <a:effectLst/>
-        </p:spPr>
-        <p:txBody>
-          <a:bodyPr rtlCol="0" anchor="ctr"/>
-          <a:lstStyle/>
-          <a:p>
-            <a:pPr algn="ctr"/>
-          </a:p>
-        </p:txBody>
-      </p:sp>
-      <p:sp>
-        <p:nvSpPr>
-          <p:cNvPr id="16" name="TextBox 15"/>
-          <p:cNvSpPr txBox="1"/>
-          <p:nvPr/>
-        </p:nvSpPr>
-        <p:spPr>
-          <a:xfrm>
-            <a:off x="457200" y="3154680"/>
-            <a:ext cx="3291840" cy="548640"/>
-          </a:xfrm>
-          <a:prstGeom prst="rect">
-            <a:avLst/>
-          </a:prstGeom>
-          <a:noFill/>
-        </p:spPr>
-        <p:txBody>
-          <a:bodyPr wrap="square" lIns="0" rIns="0" tIns="0" bIns="0" anchor="ctr">
-            <a:spAutoFit/>
-          </a:bodyPr>
-          <a:lstStyle/>
-          <a:p>
-            <a:pPr algn="l"/>
-            <a:r>
-              <a:rPr sz="1200" b="1">
-                <a:solidFill>
-                  <a:srgbClr val="0B2545"/>
-                </a:solidFill>
-                <a:latin typeface="Arial"/>
-              </a:rPr>
-              <a:t>Kode 20 jalur belum teruji beban penuh</a:t>
-            </a:r>
-          </a:p>
-        </p:txBody>
-      </p:sp>
-      <p:sp>
-        <p:nvSpPr>
-          <p:cNvPr id="17" name="TextBox 16"/>
-          <p:cNvSpPr txBox="1"/>
-          <p:nvPr/>
-        </p:nvSpPr>
-        <p:spPr>
-          <a:xfrm>
-            <a:off x="4023360" y="3154680"/>
-            <a:ext cx="4663440" cy="548640"/>
-          </a:xfrm>
-          <a:prstGeom prst="rect">
-            <a:avLst/>
-          </a:prstGeom>
-          <a:noFill/>
-        </p:spPr>
-        <p:txBody>
-          <a:bodyPr wrap="square" lIns="0" rIns="0" tIns="0" bIns="0" anchor="ctr">
-            <a:spAutoFit/>
-          </a:bodyPr>
-          <a:lstStyle/>
-          <a:p>
-            <a:pPr algn="l"/>
-            <a:r>
-              <a:rPr sz="1100" b="0">
-                <a:solidFill>
-                  <a:srgbClr val="595959"/>
-                </a:solidFill>
-                <a:latin typeface="Arial"/>
-              </a:rPr>
-              <a:t>Uji bertahap 5 &gt; 10 &gt; 20; level shifter / 330 Ω bila LED berkedip</a:t>
-            </a:r>
-          </a:p>
-        </p:txBody>
-      </p:sp>
-      <p:sp>
-        <p:nvSpPr>
-          <p:cNvPr id="18" name="Rectangle 17"/>
-          <p:cNvSpPr/>
-          <p:nvPr/>
-        </p:nvSpPr>
-        <p:spPr>
-          <a:xfrm>
-            <a:off x="457200" y="3794760"/>
-            <a:ext cx="8229600" cy="6350"/>
-          </a:xfrm>
-          <a:prstGeom prst="rect">
-            <a:avLst/>
-          </a:prstGeom>
-          <a:solidFill>
-            <a:srgbClr val="D9D9D9"/>
-          </a:solidFill>
-          <a:ln>
-            <a:noFill/>
-          </a:ln>
-          <a:effectLst/>
-        </p:spPr>
-        <p:txBody>
-          <a:bodyPr rtlCol="0" anchor="ctr"/>
-          <a:lstStyle/>
-          <a:p>
-            <a:pPr algn="ctr"/>
-          </a:p>
-        </p:txBody>
-      </p:sp>
-      <p:sp>
-        <p:nvSpPr>
-          <p:cNvPr id="19" name="Rectangle 18"/>
-          <p:cNvSpPr/>
-          <p:nvPr/>
-        </p:nvSpPr>
-        <p:spPr>
-          <a:xfrm>
-            <a:off x="457200" y="3977639"/>
-            <a:ext cx="8229600" cy="502920"/>
-          </a:xfrm>
-          <a:prstGeom prst="rect">
-            <a:avLst/>
-          </a:prstGeom>
-          <a:solidFill>
-            <a:srgbClr val="F2F4F7"/>
-          </a:solidFill>
-          <a:ln>
-            <a:noFill/>
-          </a:ln>
-          <a:effectLst/>
-        </p:spPr>
-        <p:txBody>
-          <a:bodyPr rtlCol="0" anchor="ctr"/>
-          <a:lstStyle/>
-          <a:p>
-            <a:pPr algn="ctr"/>
-          </a:p>
-        </p:txBody>
-      </p:sp>
-      <p:sp>
-        <p:nvSpPr>
-          <p:cNvPr id="20" name="Rectangle 19"/>
-          <p:cNvSpPr/>
-          <p:nvPr/>
-        </p:nvSpPr>
-        <p:spPr>
-          <a:xfrm>
-            <a:off x="457200" y="3977639"/>
-            <a:ext cx="54864" cy="502920"/>
-          </a:xfrm>
-          <a:prstGeom prst="rect">
-            <a:avLst/>
-          </a:prstGeom>
-          <a:solidFill>
-            <a:srgbClr val="0B2545"/>
-          </a:solidFill>
-          <a:ln>
-            <a:noFill/>
-          </a:ln>
-          <a:effectLst/>
-        </p:spPr>
-        <p:txBody>
-          <a:bodyPr rtlCol="0" anchor="ctr"/>
-          <a:lstStyle/>
-          <a:p>
-            <a:pPr algn="ctr"/>
-          </a:p>
-        </p:txBody>
-      </p:sp>
-      <p:sp>
-        <p:nvSpPr>
-          <p:cNvPr id="21" name="TextBox 20"/>
-          <p:cNvSpPr txBox="1"/>
-          <p:nvPr/>
-        </p:nvSpPr>
-        <p:spPr>
-          <a:xfrm>
-            <a:off x="685800" y="3977639"/>
-            <a:ext cx="7863840" cy="502920"/>
-          </a:xfrm>
-          <a:prstGeom prst="rect">
-            <a:avLst/>
-          </a:prstGeom>
-          <a:noFill/>
-        </p:spPr>
-        <p:txBody>
-          <a:bodyPr wrap="square" lIns="0" rIns="0" tIns="0" bIns="0" anchor="ctr">
-            <a:spAutoFit/>
-          </a:bodyPr>
-          <a:lstStyle/>
-          <a:p>
-            <a:pPr algn="l"/>
-            <a:r>
-              <a:rPr sz="1100" b="1">
-                <a:solidFill>
-                  <a:srgbClr val="0B2545"/>
-                </a:solidFill>
-                <a:latin typeface="Arial"/>
-              </a:rPr>
-              <a:t>Deviasi: penyolderan terlambat ±1 pekan; kode sesuai jadwal; uji penuh digeser ke Pekan 8.</a:t>
-            </a:r>
-          </a:p>
-        </p:txBody>
-      </p:sp>
+      <p:graphicFrame>
+        <p:nvGraphicFramePr>
+          <p:cNvPr id="7" name="Table 6"/>
+          <p:cNvGraphicFramePr>
+            <a:graphicFrameLocks noGrp="1"/>
+          </p:cNvGraphicFramePr>
+          <p:nvPr/>
+        </p:nvGraphicFramePr>
+        <p:xfrm>
+          <a:off x="457200" y="1280160"/>
+          <a:ext cx="8229600" cy="3145536"/>
+        </p:xfrm>
+        <a:graphic>
+          <a:graphicData uri="http://schemas.openxmlformats.org/drawingml/2006/table">
+            <a:tbl>
+              <a:tblPr firstRow="1" bandRow="1">
+                <a:tableStyleId>{5C22544A-7EE6-4342-B048-85BDC9FD1C3A}</a:tableStyleId>
+              </a:tblPr>
+              <a:tblGrid>
+                <a:gridCol w="2377440"/>
+                <a:gridCol w="5852160"/>
+              </a:tblGrid>
+              <a:tr h="393192">
+                <a:tc>
+                  <a:txBody>
+                    <a:bodyPr/>
+                    <a:lstStyle/>
+                    <a:p>
+                      <a:r>
+                        <a:rPr sz="1100" b="1">
+                          <a:solidFill>
+                            <a:srgbClr val="FFFFFF"/>
+                          </a:solidFill>
+                          <a:latin typeface="Arial"/>
+                        </a:rPr>
+                        <a:t>Parameter</a:t>
+                      </a:r>
+                    </a:p>
+                  </a:txBody>
+                  <a:tcPr anchor="ctr" marL="109728">
+                    <a:solidFill>
+                      <a:srgbClr val="0B2545"/>
+                    </a:solidFill>
+                  </a:tcPr>
+                </a:tc>
+                <a:tc>
+                  <a:txBody>
+                    <a:bodyPr/>
+                    <a:lstStyle/>
+                    <a:p>
+                      <a:r>
+                        <a:rPr sz="1100" b="1">
+                          <a:solidFill>
+                            <a:srgbClr val="FFFFFF"/>
+                          </a:solidFill>
+                          <a:latin typeface="Arial"/>
+                        </a:rPr>
+                        <a:t>Spesifikasi</a:t>
+                      </a:r>
+                    </a:p>
+                  </a:txBody>
+                  <a:tcPr anchor="ctr" marL="109728">
+                    <a:solidFill>
+                      <a:srgbClr val="0B2545"/>
+                    </a:solidFill>
+                  </a:tcPr>
+                </a:tc>
+              </a:tr>
+              <a:tr h="393192">
+                <a:tc>
+                  <a:txBody>
+                    <a:bodyPr/>
+                    <a:lstStyle/>
+                    <a:p>
+                      <a:r>
+                        <a:rPr sz="1100" b="1">
+                          <a:solidFill>
+                            <a:srgbClr val="0B2545"/>
+                          </a:solidFill>
+                          <a:latin typeface="Arial"/>
+                        </a:rPr>
+                        <a:t>Spektrum / sudut deteksi</a:t>
+                      </a:r>
+                    </a:p>
+                  </a:txBody>
+                  <a:tcPr anchor="ctr" marL="109728">
+                    <a:solidFill>
+                      <a:srgbClr val="FFFFFF"/>
+                    </a:solidFill>
+                  </a:tcPr>
+                </a:tc>
+                <a:tc>
+                  <a:txBody>
+                    <a:bodyPr/>
+                    <a:lstStyle/>
+                    <a:p>
+                      <a:r>
+                        <a:rPr sz="1100" b="0">
+                          <a:solidFill>
+                            <a:srgbClr val="595959"/>
+                          </a:solidFill>
+                          <a:latin typeface="Arial"/>
+                        </a:rPr>
+                        <a:t>±760–1100 nm (IR dekat) / ±60°</a:t>
+                      </a:r>
+                    </a:p>
+                  </a:txBody>
+                  <a:tcPr anchor="ctr" marL="109728">
+                    <a:solidFill>
+                      <a:srgbClr val="FFFFFF"/>
+                    </a:solidFill>
+                  </a:tcPr>
+                </a:tc>
+              </a:tr>
+              <a:tr h="393192">
+                <a:tc>
+                  <a:txBody>
+                    <a:bodyPr/>
+                    <a:lstStyle/>
+                    <a:p>
+                      <a:r>
+                        <a:rPr sz="1100" b="1">
+                          <a:solidFill>
+                            <a:srgbClr val="0B2545"/>
+                          </a:solidFill>
+                          <a:latin typeface="Arial"/>
+                        </a:rPr>
+                        <a:t>Jarak deteksi (tipikal)</a:t>
+                      </a:r>
+                    </a:p>
+                  </a:txBody>
+                  <a:tcPr anchor="ctr" marL="109728">
+                    <a:solidFill>
+                      <a:srgbClr val="F2F4F7"/>
+                    </a:solidFill>
+                  </a:tcPr>
+                </a:tc>
+                <a:tc>
+                  <a:txBody>
+                    <a:bodyPr/>
+                    <a:lstStyle/>
+                    <a:p>
+                      <a:r>
+                        <a:rPr sz="1100" b="0">
+                          <a:solidFill>
+                            <a:srgbClr val="595959"/>
+                          </a:solidFill>
+                          <a:latin typeface="Arial"/>
+                        </a:rPr>
+                        <a:t>±20 cm (api korek) hingga ±80 cm (api besar); diatur potensiometer</a:t>
+                      </a:r>
+                    </a:p>
+                  </a:txBody>
+                  <a:tcPr anchor="ctr" marL="109728">
+                    <a:solidFill>
+                      <a:srgbClr val="F2F4F7"/>
+                    </a:solidFill>
+                  </a:tcPr>
+                </a:tc>
+              </a:tr>
+              <a:tr h="393192">
+                <a:tc>
+                  <a:txBody>
+                    <a:bodyPr/>
+                    <a:lstStyle/>
+                    <a:p>
+                      <a:r>
+                        <a:rPr sz="1100" b="1">
+                          <a:solidFill>
+                            <a:srgbClr val="0B2545"/>
+                          </a:solidFill>
+                          <a:latin typeface="Arial"/>
+                        </a:rPr>
+                        <a:t>Rentang scan ADC</a:t>
+                      </a:r>
+                    </a:p>
+                  </a:txBody>
+                  <a:tcPr anchor="ctr" marL="109728">
+                    <a:solidFill>
+                      <a:srgbClr val="FFFFFF"/>
+                    </a:solidFill>
+                  </a:tcPr>
+                </a:tc>
+                <a:tc>
+                  <a:txBody>
+                    <a:bodyPr/>
+                    <a:lstStyle/>
+                    <a:p>
+                      <a:r>
+                        <a:rPr sz="1100" b="0">
+                          <a:solidFill>
+                            <a:srgbClr val="595959"/>
+                          </a:solidFill>
+                          <a:latin typeface="Arial"/>
+                        </a:rPr>
+                        <a:t>0–4095 (12 bit), atenuasi 11 dB ≈ 0–3,3 V; nilai turun saat ada api</a:t>
+                      </a:r>
+                    </a:p>
+                  </a:txBody>
+                  <a:tcPr anchor="ctr" marL="109728">
+                    <a:solidFill>
+                      <a:srgbClr val="FFFFFF"/>
+                    </a:solidFill>
+                  </a:tcPr>
+                </a:tc>
+              </a:tr>
+              <a:tr h="393192">
+                <a:tc>
+                  <a:txBody>
+                    <a:bodyPr/>
+                    <a:lstStyle/>
+                    <a:p>
+                      <a:r>
+                        <a:rPr sz="1100" b="1">
+                          <a:solidFill>
+                            <a:srgbClr val="0B2545"/>
+                          </a:solidFill>
+                          <a:latin typeface="Arial"/>
+                        </a:rPr>
+                        <a:t>Ambang deteksi</a:t>
+                      </a:r>
+                    </a:p>
+                  </a:txBody>
+                  <a:tcPr anchor="ctr" marL="109728">
+                    <a:solidFill>
+                      <a:srgbClr val="F2F4F7"/>
+                    </a:solidFill>
+                  </a:tcPr>
+                </a:tc>
+                <a:tc>
+                  <a:txBody>
+                    <a:bodyPr/>
+                    <a:lstStyle/>
+                    <a:p>
+                      <a:r>
+                        <a:rPr sz="1100" b="0">
+                          <a:solidFill>
+                            <a:srgbClr val="595959"/>
+                          </a:solidFill>
+                          <a:latin typeface="Arial"/>
+                        </a:rPr>
+                        <a:t>Api bila &lt; 1500 (≈1,21 V); aman lagi bila &gt; 1800 (≈1,45 V)</a:t>
+                      </a:r>
+                    </a:p>
+                  </a:txBody>
+                  <a:tcPr anchor="ctr" marL="109728">
+                    <a:solidFill>
+                      <a:srgbClr val="F2F4F7"/>
+                    </a:solidFill>
+                  </a:tcPr>
+                </a:tc>
+              </a:tr>
+              <a:tr h="393192">
+                <a:tc>
+                  <a:txBody>
+                    <a:bodyPr/>
+                    <a:lstStyle/>
+                    <a:p>
+                      <a:r>
+                        <a:rPr sz="1100" b="1">
+                          <a:solidFill>
+                            <a:srgbClr val="0B2545"/>
+                          </a:solidFill>
+                          <a:latin typeface="Arial"/>
+                        </a:rPr>
+                        <a:t>Periode scan</a:t>
+                      </a:r>
+                    </a:p>
+                  </a:txBody>
+                  <a:tcPr anchor="ctr" marL="109728">
+                    <a:solidFill>
+                      <a:srgbClr val="FFFFFF"/>
+                    </a:solidFill>
+                  </a:tcPr>
+                </a:tc>
+                <a:tc>
+                  <a:txBody>
+                    <a:bodyPr/>
+                    <a:lstStyle/>
+                    <a:p>
+                      <a:r>
+                        <a:rPr sz="1100" b="0">
+                          <a:solidFill>
+                            <a:srgbClr val="595959"/>
+                          </a:solidFill>
+                          <a:latin typeface="Arial"/>
+                        </a:rPr>
+                        <a:t>50 ms (20 Hz), rata-rata 8 sampel, konfirmasi 3 scan: deteksi ±150 ms</a:t>
+                      </a:r>
+                    </a:p>
+                  </a:txBody>
+                  <a:tcPr anchor="ctr" marL="109728">
+                    <a:solidFill>
+                      <a:srgbClr val="FFFFFF"/>
+                    </a:solidFill>
+                  </a:tcPr>
+                </a:tc>
+              </a:tr>
+              <a:tr h="393192">
+                <a:tc>
+                  <a:txBody>
+                    <a:bodyPr/>
+                    <a:lstStyle/>
+                    <a:p>
+                      <a:r>
+                        <a:rPr sz="1100" b="1">
+                          <a:solidFill>
+                            <a:srgbClr val="0B2545"/>
+                          </a:solidFill>
+                          <a:latin typeface="Arial"/>
+                        </a:rPr>
+                        <a:t>Pin AO (ADC1)</a:t>
+                      </a:r>
+                    </a:p>
+                  </a:txBody>
+                  <a:tcPr anchor="ctr" marL="109728">
+                    <a:solidFill>
+                      <a:srgbClr val="F2F4F7"/>
+                    </a:solidFill>
+                  </a:tcPr>
+                </a:tc>
+                <a:tc>
+                  <a:txBody>
+                    <a:bodyPr/>
+                    <a:lstStyle/>
+                    <a:p>
+                      <a:r>
+                        <a:rPr sz="1100" b="0">
+                          <a:solidFill>
+                            <a:srgbClr val="595959"/>
+                          </a:solidFill>
+                          <a:latin typeface="Arial"/>
+                        </a:rPr>
+                        <a:t>GPIO 32, 33, 34 untuk jalur #3, #18, #19; VCC 3,3 V</a:t>
+                      </a:r>
+                    </a:p>
+                  </a:txBody>
+                  <a:tcPr anchor="ctr" marL="109728">
+                    <a:solidFill>
+                      <a:srgbClr val="F2F4F7"/>
+                    </a:solidFill>
+                  </a:tcPr>
+                </a:tc>
+              </a:tr>
+              <a:tr h="393192">
+                <a:tc>
+                  <a:txBody>
+                    <a:bodyPr/>
+                    <a:lstStyle/>
+                    <a:p>
+                      <a:r>
+                        <a:rPr sz="1100" b="1">
+                          <a:solidFill>
+                            <a:srgbClr val="0B2545"/>
+                          </a:solidFill>
+                          <a:latin typeface="Arial"/>
+                        </a:rPr>
+                        <a:t>Jarak deteksi terukur</a:t>
+                      </a:r>
+                    </a:p>
+                  </a:txBody>
+                  <a:tcPr anchor="ctr" marL="109728">
+                    <a:solidFill>
+                      <a:srgbClr val="FFFFFF"/>
+                    </a:solidFill>
+                  </a:tcPr>
+                </a:tc>
+                <a:tc>
+                  <a:txBody>
+                    <a:bodyPr/>
+                    <a:lstStyle/>
+                    <a:p>
+                      <a:r>
+                        <a:rPr sz="1100" b="0">
+                          <a:solidFill>
+                            <a:srgbClr val="595959"/>
+                          </a:solidFill>
+                          <a:latin typeface="Arial"/>
+                        </a:rPr>
+                        <a:t>[isi hasil ukur di maket: … cm]</a:t>
+                      </a:r>
+                    </a:p>
+                  </a:txBody>
+                  <a:tcPr anchor="ctr" marL="109728">
+                    <a:solidFill>
+                      <a:srgbClr val="FFFFFF"/>
+                    </a:solidFill>
+                  </a:tcPr>
+                </a:tc>
+              </a:tr>
+            </a:tbl>
+          </a:graphicData>
+        </a:graphic>
+      </p:graphicFrame>
     </p:spTree>
   </p:cSld>
   <p:clrMapOvr>
@@ -8539,7 +8205,7 @@
                 </a:solidFill>
                 <a:latin typeface="Georgia"/>
               </a:rPr>
-              <a:t>Progres total 72% (naik dari 54% di Pekan 5); Pekan 8 fokus integrasi dan pengujian</a:t>
+              <a:t>Kendala catu daya diatasi dengan uji 3 jalur; uji 20 jalur menunggu konektor PSU</a:t>
             </a:r>
           </a:p>
         </p:txBody>
@@ -8634,7 +8300,7 @@
                 </a:solidFill>
                 <a:latin typeface="Arial"/>
               </a:rPr>
-              <a:t>Sumber: estimasi tim; bobot 20/25/25/15/10/5 (dalam % dari total proyek).</a:t>
+              <a:t>Catatan: deviasi = penyolderan terlambat ±1 pekan; kode sesuai jadwal; uji 20 jalur digeser ke Pekan 8.</a:t>
             </a:r>
           </a:p>
         </p:txBody>
@@ -8670,6 +8336,684 @@
                 <a:latin typeface="Arial"/>
               </a:rPr>
               <a:t>SAFE-EXIT  |  Pekan 7      7</a:t>
+            </a:r>
+          </a:p>
+        </p:txBody>
+      </p:sp>
+      <p:sp>
+        <p:nvSpPr>
+          <p:cNvPr id="7" name="TextBox 6"/>
+          <p:cNvSpPr txBox="1"/>
+          <p:nvPr/>
+        </p:nvSpPr>
+        <p:spPr>
+          <a:xfrm>
+            <a:off x="457200" y="1280160"/>
+            <a:ext cx="3291840" cy="274320"/>
+          </a:xfrm>
+          <a:prstGeom prst="rect">
+            <a:avLst/>
+          </a:prstGeom>
+          <a:noFill/>
+        </p:spPr>
+        <p:txBody>
+          <a:bodyPr wrap="square" lIns="0" rIns="0" tIns="0" bIns="0" anchor="t">
+            <a:spAutoFit/>
+          </a:bodyPr>
+          <a:lstStyle/>
+          <a:p>
+            <a:pPr algn="l"/>
+            <a:r>
+              <a:rPr sz="1000" b="1">
+                <a:solidFill>
+                  <a:srgbClr val="8A9BB0"/>
+                </a:solidFill>
+                <a:latin typeface="Arial"/>
+              </a:rPr>
+              <a:t>Kendala</a:t>
+            </a:r>
+          </a:p>
+        </p:txBody>
+      </p:sp>
+      <p:sp>
+        <p:nvSpPr>
+          <p:cNvPr id="8" name="TextBox 7"/>
+          <p:cNvSpPr txBox="1"/>
+          <p:nvPr/>
+        </p:nvSpPr>
+        <p:spPr>
+          <a:xfrm>
+            <a:off x="4023360" y="1280160"/>
+            <a:ext cx="4572000" cy="274320"/>
+          </a:xfrm>
+          <a:prstGeom prst="rect">
+            <a:avLst/>
+          </a:prstGeom>
+          <a:noFill/>
+        </p:spPr>
+        <p:txBody>
+          <a:bodyPr wrap="square" lIns="0" rIns="0" tIns="0" bIns="0" anchor="t">
+            <a:spAutoFit/>
+          </a:bodyPr>
+          <a:lstStyle/>
+          <a:p>
+            <a:pPr algn="l"/>
+            <a:r>
+              <a:rPr sz="1000" b="1">
+                <a:solidFill>
+                  <a:srgbClr val="8A9BB0"/>
+                </a:solidFill>
+                <a:latin typeface="Arial"/>
+              </a:rPr>
+              <a:t>Solusi / mitigasi</a:t>
+            </a:r>
+          </a:p>
+        </p:txBody>
+      </p:sp>
+      <p:sp>
+        <p:nvSpPr>
+          <p:cNvPr id="9" name="Rectangle 8"/>
+          <p:cNvSpPr/>
+          <p:nvPr/>
+        </p:nvSpPr>
+        <p:spPr>
+          <a:xfrm>
+            <a:off x="457200" y="1554480"/>
+            <a:ext cx="8229600" cy="9525"/>
+          </a:xfrm>
+          <a:prstGeom prst="rect">
+            <a:avLst/>
+          </a:prstGeom>
+          <a:solidFill>
+            <a:srgbClr val="0B2545"/>
+          </a:solidFill>
+          <a:ln>
+            <a:noFill/>
+          </a:ln>
+          <a:effectLst/>
+        </p:spPr>
+        <p:txBody>
+          <a:bodyPr rtlCol="0" anchor="ctr"/>
+          <a:lstStyle/>
+          <a:p>
+            <a:pPr algn="ctr"/>
+          </a:p>
+        </p:txBody>
+      </p:sp>
+      <p:sp>
+        <p:nvSpPr>
+          <p:cNvPr id="10" name="TextBox 9"/>
+          <p:cNvSpPr txBox="1"/>
+          <p:nvPr/>
+        </p:nvSpPr>
+        <p:spPr>
+          <a:xfrm>
+            <a:off x="457200" y="1691640"/>
+            <a:ext cx="3291840" cy="548640"/>
+          </a:xfrm>
+          <a:prstGeom prst="rect">
+            <a:avLst/>
+          </a:prstGeom>
+          <a:noFill/>
+        </p:spPr>
+        <p:txBody>
+          <a:bodyPr wrap="square" lIns="0" rIns="0" tIns="0" bIns="0" anchor="ctr">
+            <a:spAutoFit/>
+          </a:bodyPr>
+          <a:lstStyle/>
+          <a:p>
+            <a:pPr algn="l"/>
+            <a:r>
+              <a:rPr sz="1200" b="1">
+                <a:solidFill>
+                  <a:srgbClr val="0B2545"/>
+                </a:solidFill>
+                <a:latin typeface="Arial"/>
+              </a:rPr>
+              <a:t>Arus catu 5 jalur kurang kuat; konektor PSU bermasalah</a:t>
+            </a:r>
+          </a:p>
+        </p:txBody>
+      </p:sp>
+      <p:sp>
+        <p:nvSpPr>
+          <p:cNvPr id="11" name="TextBox 10"/>
+          <p:cNvSpPr txBox="1"/>
+          <p:nvPr/>
+        </p:nvSpPr>
+        <p:spPr>
+          <a:xfrm>
+            <a:off x="4023360" y="1691640"/>
+            <a:ext cx="4663440" cy="548640"/>
+          </a:xfrm>
+          <a:prstGeom prst="rect">
+            <a:avLst/>
+          </a:prstGeom>
+          <a:noFill/>
+        </p:spPr>
+        <p:txBody>
+          <a:bodyPr wrap="square" lIns="0" rIns="0" tIns="0" bIns="0" anchor="ctr">
+            <a:spAutoFit/>
+          </a:bodyPr>
+          <a:lstStyle/>
+          <a:p>
+            <a:pPr algn="l"/>
+            <a:r>
+              <a:rPr sz="1100" b="0">
+                <a:solidFill>
+                  <a:srgbClr val="595959"/>
+                </a:solidFill>
+                <a:latin typeface="Arial"/>
+              </a:rPr>
+              <a:t>Uji disederhanakan ke 3 jalur (18 LED) dan berhasil; perbaiki / ganti konektor PSU</a:t>
+            </a:r>
+          </a:p>
+        </p:txBody>
+      </p:sp>
+      <p:sp>
+        <p:nvSpPr>
+          <p:cNvPr id="12" name="Rectangle 11"/>
+          <p:cNvSpPr/>
+          <p:nvPr/>
+        </p:nvSpPr>
+        <p:spPr>
+          <a:xfrm>
+            <a:off x="457200" y="2331720"/>
+            <a:ext cx="8229600" cy="6350"/>
+          </a:xfrm>
+          <a:prstGeom prst="rect">
+            <a:avLst/>
+          </a:prstGeom>
+          <a:solidFill>
+            <a:srgbClr val="D9D9D9"/>
+          </a:solidFill>
+          <a:ln>
+            <a:noFill/>
+          </a:ln>
+          <a:effectLst/>
+        </p:spPr>
+        <p:txBody>
+          <a:bodyPr rtlCol="0" anchor="ctr"/>
+          <a:lstStyle/>
+          <a:p>
+            <a:pPr algn="ctr"/>
+          </a:p>
+        </p:txBody>
+      </p:sp>
+      <p:sp>
+        <p:nvSpPr>
+          <p:cNvPr id="13" name="TextBox 12"/>
+          <p:cNvSpPr txBox="1"/>
+          <p:nvPr/>
+        </p:nvSpPr>
+        <p:spPr>
+          <a:xfrm>
+            <a:off x="457200" y="2423160"/>
+            <a:ext cx="3291840" cy="548640"/>
+          </a:xfrm>
+          <a:prstGeom prst="rect">
+            <a:avLst/>
+          </a:prstGeom>
+          <a:noFill/>
+        </p:spPr>
+        <p:txBody>
+          <a:bodyPr wrap="square" lIns="0" rIns="0" tIns="0" bIns="0" anchor="ctr">
+            <a:spAutoFit/>
+          </a:bodyPr>
+          <a:lstStyle/>
+          <a:p>
+            <a:pPr algn="l"/>
+            <a:r>
+              <a:rPr sz="1200" b="1">
+                <a:solidFill>
+                  <a:srgbClr val="0B2545"/>
+                </a:solidFill>
+                <a:latin typeface="Arial"/>
+              </a:rPr>
+              <a:t>Sensor api fisik hanya 3</a:t>
+            </a:r>
+          </a:p>
+        </p:txBody>
+      </p:sp>
+      <p:sp>
+        <p:nvSpPr>
+          <p:cNvPr id="14" name="TextBox 13"/>
+          <p:cNvSpPr txBox="1"/>
+          <p:nvPr/>
+        </p:nvSpPr>
+        <p:spPr>
+          <a:xfrm>
+            <a:off x="4023360" y="2423160"/>
+            <a:ext cx="4663440" cy="548640"/>
+          </a:xfrm>
+          <a:prstGeom prst="rect">
+            <a:avLst/>
+          </a:prstGeom>
+          <a:noFill/>
+        </p:spPr>
+        <p:txBody>
+          <a:bodyPr wrap="square" lIns="0" rIns="0" tIns="0" bIns="0" anchor="ctr">
+            <a:spAutoFit/>
+          </a:bodyPr>
+          <a:lstStyle/>
+          <a:p>
+            <a:pPr algn="l"/>
+            <a:r>
+              <a:rPr sz="1100" b="0">
+                <a:solidFill>
+                  <a:srgbClr val="595959"/>
+                </a:solidFill>
+                <a:latin typeface="Arial"/>
+              </a:rPr>
+              <a:t>Jalur lain disimulasikan lewat Serial pada peta penuh</a:t>
+            </a:r>
+          </a:p>
+        </p:txBody>
+      </p:sp>
+      <p:sp>
+        <p:nvSpPr>
+          <p:cNvPr id="15" name="Rectangle 14"/>
+          <p:cNvSpPr/>
+          <p:nvPr/>
+        </p:nvSpPr>
+        <p:spPr>
+          <a:xfrm>
+            <a:off x="457200" y="3063240"/>
+            <a:ext cx="8229600" cy="6350"/>
+          </a:xfrm>
+          <a:prstGeom prst="rect">
+            <a:avLst/>
+          </a:prstGeom>
+          <a:solidFill>
+            <a:srgbClr val="D9D9D9"/>
+          </a:solidFill>
+          <a:ln>
+            <a:noFill/>
+          </a:ln>
+          <a:effectLst/>
+        </p:spPr>
+        <p:txBody>
+          <a:bodyPr rtlCol="0" anchor="ctr"/>
+          <a:lstStyle/>
+          <a:p>
+            <a:pPr algn="ctr"/>
+          </a:p>
+        </p:txBody>
+      </p:sp>
+      <p:sp>
+        <p:nvSpPr>
+          <p:cNvPr id="16" name="TextBox 15"/>
+          <p:cNvSpPr txBox="1"/>
+          <p:nvPr/>
+        </p:nvSpPr>
+        <p:spPr>
+          <a:xfrm>
+            <a:off x="457200" y="3154680"/>
+            <a:ext cx="3291840" cy="548640"/>
+          </a:xfrm>
+          <a:prstGeom prst="rect">
+            <a:avLst/>
+          </a:prstGeom>
+          <a:noFill/>
+        </p:spPr>
+        <p:txBody>
+          <a:bodyPr wrap="square" lIns="0" rIns="0" tIns="0" bIns="0" anchor="ctr">
+            <a:spAutoFit/>
+          </a:bodyPr>
+          <a:lstStyle/>
+          <a:p>
+            <a:pPr algn="l"/>
+            <a:r>
+              <a:rPr sz="1200" b="1">
+                <a:solidFill>
+                  <a:srgbClr val="0B2545"/>
+                </a:solidFill>
+                <a:latin typeface="Arial"/>
+              </a:rPr>
+              <a:t>Kode 20 jalur belum teruji beban penuh</a:t>
+            </a:r>
+          </a:p>
+        </p:txBody>
+      </p:sp>
+      <p:sp>
+        <p:nvSpPr>
+          <p:cNvPr id="17" name="TextBox 16"/>
+          <p:cNvSpPr txBox="1"/>
+          <p:nvPr/>
+        </p:nvSpPr>
+        <p:spPr>
+          <a:xfrm>
+            <a:off x="4023360" y="3154680"/>
+            <a:ext cx="4663440" cy="548640"/>
+          </a:xfrm>
+          <a:prstGeom prst="rect">
+            <a:avLst/>
+          </a:prstGeom>
+          <a:noFill/>
+        </p:spPr>
+        <p:txBody>
+          <a:bodyPr wrap="square" lIns="0" rIns="0" tIns="0" bIns="0" anchor="ctr">
+            <a:spAutoFit/>
+          </a:bodyPr>
+          <a:lstStyle/>
+          <a:p>
+            <a:pPr algn="l"/>
+            <a:r>
+              <a:rPr sz="1100" b="0">
+                <a:solidFill>
+                  <a:srgbClr val="595959"/>
+                </a:solidFill>
+                <a:latin typeface="Arial"/>
+              </a:rPr>
+              <a:t>Uji bertahap 5 &gt; 10 &gt; 20; level shifter / 330 Ω bila LED berkedip</a:t>
+            </a:r>
+          </a:p>
+        </p:txBody>
+      </p:sp>
+      <p:sp>
+        <p:nvSpPr>
+          <p:cNvPr id="18" name="Rectangle 17"/>
+          <p:cNvSpPr/>
+          <p:nvPr/>
+        </p:nvSpPr>
+        <p:spPr>
+          <a:xfrm>
+            <a:off x="457200" y="3794760"/>
+            <a:ext cx="8229600" cy="6350"/>
+          </a:xfrm>
+          <a:prstGeom prst="rect">
+            <a:avLst/>
+          </a:prstGeom>
+          <a:solidFill>
+            <a:srgbClr val="D9D9D9"/>
+          </a:solidFill>
+          <a:ln>
+            <a:noFill/>
+          </a:ln>
+          <a:effectLst/>
+        </p:spPr>
+        <p:txBody>
+          <a:bodyPr rtlCol="0" anchor="ctr"/>
+          <a:lstStyle/>
+          <a:p>
+            <a:pPr algn="ctr"/>
+          </a:p>
+        </p:txBody>
+      </p:sp>
+      <p:sp>
+        <p:nvSpPr>
+          <p:cNvPr id="19" name="Rectangle 18"/>
+          <p:cNvSpPr/>
+          <p:nvPr/>
+        </p:nvSpPr>
+        <p:spPr>
+          <a:xfrm>
+            <a:off x="457200" y="3977639"/>
+            <a:ext cx="8229600" cy="502920"/>
+          </a:xfrm>
+          <a:prstGeom prst="rect">
+            <a:avLst/>
+          </a:prstGeom>
+          <a:solidFill>
+            <a:srgbClr val="F2F4F7"/>
+          </a:solidFill>
+          <a:ln>
+            <a:noFill/>
+          </a:ln>
+          <a:effectLst/>
+        </p:spPr>
+        <p:txBody>
+          <a:bodyPr rtlCol="0" anchor="ctr"/>
+          <a:lstStyle/>
+          <a:p>
+            <a:pPr algn="ctr"/>
+          </a:p>
+        </p:txBody>
+      </p:sp>
+      <p:sp>
+        <p:nvSpPr>
+          <p:cNvPr id="20" name="Rectangle 19"/>
+          <p:cNvSpPr/>
+          <p:nvPr/>
+        </p:nvSpPr>
+        <p:spPr>
+          <a:xfrm>
+            <a:off x="457200" y="3977639"/>
+            <a:ext cx="54864" cy="502920"/>
+          </a:xfrm>
+          <a:prstGeom prst="rect">
+            <a:avLst/>
+          </a:prstGeom>
+          <a:solidFill>
+            <a:srgbClr val="0B2545"/>
+          </a:solidFill>
+          <a:ln>
+            <a:noFill/>
+          </a:ln>
+          <a:effectLst/>
+        </p:spPr>
+        <p:txBody>
+          <a:bodyPr rtlCol="0" anchor="ctr"/>
+          <a:lstStyle/>
+          <a:p>
+            <a:pPr algn="ctr"/>
+          </a:p>
+        </p:txBody>
+      </p:sp>
+      <p:sp>
+        <p:nvSpPr>
+          <p:cNvPr id="21" name="TextBox 20"/>
+          <p:cNvSpPr txBox="1"/>
+          <p:nvPr/>
+        </p:nvSpPr>
+        <p:spPr>
+          <a:xfrm>
+            <a:off x="685800" y="3977639"/>
+            <a:ext cx="7863840" cy="502920"/>
+          </a:xfrm>
+          <a:prstGeom prst="rect">
+            <a:avLst/>
+          </a:prstGeom>
+          <a:noFill/>
+        </p:spPr>
+        <p:txBody>
+          <a:bodyPr wrap="square" lIns="0" rIns="0" tIns="0" bIns="0" anchor="ctr">
+            <a:spAutoFit/>
+          </a:bodyPr>
+          <a:lstStyle/>
+          <a:p>
+            <a:pPr algn="l"/>
+            <a:r>
+              <a:rPr sz="1100" b="1">
+                <a:solidFill>
+                  <a:srgbClr val="0B2545"/>
+                </a:solidFill>
+                <a:latin typeface="Arial"/>
+              </a:rPr>
+              <a:t>Deviasi: penyolderan terlambat ±1 pekan; kode sesuai jadwal; uji 20 jalur digeser ke Pekan 8.</a:t>
+            </a:r>
+          </a:p>
+        </p:txBody>
+      </p:sp>
+    </p:spTree>
+  </p:cSld>
+  <p:clrMapOvr>
+    <a:masterClrMapping/>
+  </p:clrMapOvr>
+</p:sld>
+</file>
+
+<file path=ppt/slides/slide8.xml><?xml version="1.0" encoding="utf-8"?>
+<p:sld xmlns:a="http://schemas.openxmlformats.org/drawingml/2006/main" xmlns:p="http://schemas.openxmlformats.org/presentationml/2006/main" xmlns:r="http://schemas.openxmlformats.org/officeDocument/2006/relationships">
+  <p:cSld>
+    <p:spTree>
+      <p:nvGrpSpPr>
+        <p:cNvPr id="1" name=""/>
+        <p:cNvGrpSpPr/>
+        <p:nvPr/>
+      </p:nvGrpSpPr>
+      <p:grpSpPr/>
+      <p:sp>
+        <p:nvSpPr>
+          <p:cNvPr id="2" name="TextBox 1"/>
+          <p:cNvSpPr txBox="1"/>
+          <p:nvPr/>
+        </p:nvSpPr>
+        <p:spPr>
+          <a:xfrm>
+            <a:off x="457200" y="320040"/>
+            <a:ext cx="8229600" cy="685800"/>
+          </a:xfrm>
+          <a:prstGeom prst="rect">
+            <a:avLst/>
+          </a:prstGeom>
+          <a:noFill/>
+        </p:spPr>
+        <p:txBody>
+          <a:bodyPr wrap="square" lIns="0" rIns="0" tIns="0" bIns="0" anchor="t">
+            <a:spAutoFit/>
+          </a:bodyPr>
+          <a:lstStyle/>
+          <a:p>
+            <a:pPr algn="l"/>
+            <a:r>
+              <a:rPr sz="2000" b="0">
+                <a:solidFill>
+                  <a:srgbClr val="0B2545"/>
+                </a:solidFill>
+                <a:latin typeface="Georgia"/>
+              </a:rPr>
+              <a:t>Progres total 72% (naik dari 54% di Pekan 5); Pekan 8 fokus maket dan uji end-to-end</a:t>
+            </a:r>
+          </a:p>
+        </p:txBody>
+      </p:sp>
+      <p:sp>
+        <p:nvSpPr>
+          <p:cNvPr id="3" name="Rectangle 2"/>
+          <p:cNvSpPr/>
+          <p:nvPr/>
+        </p:nvSpPr>
+        <p:spPr>
+          <a:xfrm>
+            <a:off x="457200" y="1024128"/>
+            <a:ext cx="8229600" cy="15875"/>
+          </a:xfrm>
+          <a:prstGeom prst="rect">
+            <a:avLst/>
+          </a:prstGeom>
+          <a:solidFill>
+            <a:srgbClr val="0B2545"/>
+          </a:solidFill>
+          <a:ln>
+            <a:noFill/>
+          </a:ln>
+          <a:effectLst/>
+        </p:spPr>
+        <p:txBody>
+          <a:bodyPr rtlCol="0" anchor="ctr"/>
+          <a:lstStyle/>
+          <a:p>
+            <a:pPr algn="ctr"/>
+          </a:p>
+        </p:txBody>
+      </p:sp>
+      <p:sp>
+        <p:nvSpPr>
+          <p:cNvPr id="4" name="Rectangle 3"/>
+          <p:cNvSpPr/>
+          <p:nvPr/>
+        </p:nvSpPr>
+        <p:spPr>
+          <a:xfrm>
+            <a:off x="457200" y="4681728"/>
+            <a:ext cx="8229600" cy="6350"/>
+          </a:xfrm>
+          <a:prstGeom prst="rect">
+            <a:avLst/>
+          </a:prstGeom>
+          <a:solidFill>
+            <a:srgbClr val="D9D9D9"/>
+          </a:solidFill>
+          <a:ln>
+            <a:noFill/>
+          </a:ln>
+          <a:effectLst/>
+        </p:spPr>
+        <p:txBody>
+          <a:bodyPr rtlCol="0" anchor="ctr"/>
+          <a:lstStyle/>
+          <a:p>
+            <a:pPr algn="ctr"/>
+          </a:p>
+        </p:txBody>
+      </p:sp>
+      <p:sp>
+        <p:nvSpPr>
+          <p:cNvPr id="5" name="TextBox 4"/>
+          <p:cNvSpPr txBox="1"/>
+          <p:nvPr/>
+        </p:nvSpPr>
+        <p:spPr>
+          <a:xfrm>
+            <a:off x="457200" y="4754880"/>
+            <a:ext cx="6583680" cy="228600"/>
+          </a:xfrm>
+          <a:prstGeom prst="rect">
+            <a:avLst/>
+          </a:prstGeom>
+          <a:noFill/>
+        </p:spPr>
+        <p:txBody>
+          <a:bodyPr wrap="square" lIns="0" rIns="0" tIns="0" bIns="0" anchor="t">
+            <a:spAutoFit/>
+          </a:bodyPr>
+          <a:lstStyle/>
+          <a:p>
+            <a:pPr algn="l"/>
+            <a:r>
+              <a:rPr sz="800" b="0">
+                <a:solidFill>
+                  <a:srgbClr val="8A9BB0"/>
+                </a:solidFill>
+                <a:latin typeface="Arial"/>
+              </a:rPr>
+              <a:t>Sumber: estimasi tim; bobot 20/25/25/15/10/5 (dalam % dari total proyek).</a:t>
+            </a:r>
+          </a:p>
+        </p:txBody>
+      </p:sp>
+      <p:sp>
+        <p:nvSpPr>
+          <p:cNvPr id="6" name="TextBox 5"/>
+          <p:cNvSpPr txBox="1"/>
+          <p:nvPr/>
+        </p:nvSpPr>
+        <p:spPr>
+          <a:xfrm>
+            <a:off x="6400800" y="4754880"/>
+            <a:ext cx="2286000" cy="228600"/>
+          </a:xfrm>
+          <a:prstGeom prst="rect">
+            <a:avLst/>
+          </a:prstGeom>
+          <a:noFill/>
+        </p:spPr>
+        <p:txBody>
+          <a:bodyPr wrap="square" lIns="0" rIns="0" tIns="0" bIns="0" anchor="t">
+            <a:spAutoFit/>
+          </a:bodyPr>
+          <a:lstStyle/>
+          <a:p>
+            <a:pPr algn="r"/>
+            <a:r>
+              <a:rPr sz="800" b="0">
+                <a:solidFill>
+                  <a:srgbClr val="8A9BB0"/>
+                </a:solidFill>
+                <a:latin typeface="Arial"/>
+              </a:rPr>
+              <a:t>SAFE-EXIT  |  Pekan 7      8</a:t>
             </a:r>
           </a:p>
         </p:txBody>
@@ -8861,7 +9205,7 @@
                 </a:solidFill>
                 <a:latin typeface="Arial"/>
               </a:rPr>
-              <a:t>–  Ganti / perbaiki kabel PSU, uji 20 jalur 5 V</a:t>
+              <a:t>–  Tempel strip + sensor 3 jalur di maket Gedung K</a:t>
             </a:r>
           </a:p>
           <a:p>
@@ -8877,7 +9221,7 @@
                 </a:solidFill>
                 <a:latin typeface="Arial"/>
               </a:rPr>
-              <a:t>–  Pasang strip + sensor di maket Gedung K</a:t>
+              <a:t>–  Perbaiki konektor PSU, uji 20 jalur 5 V</a:t>
             </a:r>
           </a:p>
           <a:p>
@@ -8893,7 +9237,7 @@
                 </a:solidFill>
                 <a:latin typeface="Arial"/>
               </a:rPr>
-              <a:t>–  Kalibrasi sensor, ukur daya, uji end-to-end</a:t>
+              <a:t>–  Ukur jarak deteksi, kalibrasi sensor, ukur daya</a:t>
             </a:r>
           </a:p>
           <a:p>
@@ -8909,7 +9253,7 @@
                 </a:solidFill>
                 <a:latin typeface="Arial"/>
               </a:rPr>
-              <a:t>–  Relay, DFPlayer, presentasi progres</a:t>
+              <a:t>–  Uji end-to-end, relay, DFPlayer, presentasi progres</a:t>
             </a:r>
           </a:p>
         </p:txBody>

</xml_diff>

<commit_message>
fix: Week7 input api hanya dari sensor AO (ALLOW_TEXT_SIM 0), sesuaikan laporan, PPT, README
</commit_message>
<xml_diff>
--- a/Week7/PPT_SAFE-EXIT_Pekan7_Kelompok21_MBB.pptx
+++ b/Week7/PPT_SAFE-EXIT_Pekan7_Kelompok21_MBB.pptx
@@ -6489,7 +6489,7 @@
                 </a:solidFill>
                 <a:latin typeface="Arial"/>
               </a:rPr>
-              <a:t>Jalur terkena api (sensor atau simulasi)</a:t>
+              <a:t>Jalur terkena api (dari sensor AO)</a:t>
             </a:r>
           </a:p>
         </p:txBody>
@@ -6927,7 +6927,7 @@
                 </a:solidFill>
                 <a:latin typeface="Arial"/>
               </a:rPr>
-              <a:t>Catatan: 18 LED ≈ 0,24 A (perkiraan dari 0,45 A untuk 34 LED). Jalur lain disimulasikan lewat Serial.</a:t>
+              <a:t>Catatan: 18 LED ≈ 0,24 A (perkiraan dari 0,45 A untuk 34 LED). Input api hanya dari sensor AO.</a:t>
             </a:r>
           </a:p>
         </p:txBody>
@@ -8605,7 +8605,7 @@
                 </a:solidFill>
                 <a:latin typeface="Arial"/>
               </a:rPr>
-              <a:t>Jalur lain disimulasikan lewat Serial pada peta penuh</a:t>
+              <a:t>Input api hanya dari sensor; jalur tanpa sensor dianggap aman</a:t>
             </a:r>
           </a:p>
         </p:txBody>

</xml_diff>